<commit_message>
Add theme deck builder (cover slide, auto font sizing) and regenerate template
Co-Authored-By: Claude Opus 5.5 <noreply@anthropic.com>
Claude-Session: https://claude.ai/code/session_01XCo1fEaxRp1ZKVxVZ14mEu
</commit_message>
<xml_diff>
--- a/template/ochiai_format_template.pptx
+++ b/template/ochiai_format_template.pptx
@@ -611,12 +611,12 @@
         </p:nvSpPr>
         <p:spPr>
           <a:xfrm>
-            <a:off x="457200" y="1645920"/>
-            <a:ext cx="3794760" cy="1417320"/>
+            <a:off x="457200" y="1508760"/>
+            <a:ext cx="3794760" cy="1508760"/>
           </a:xfrm>
           <a:prstGeom prst="rect">
             <a:avLst>
-              <a:gd name="adj" fmla="val 5161"/>
+              <a:gd name="adj" fmla="val 4848"/>
             </a:avLst>
           </a:prstGeom>
           <a:solidFill>
@@ -633,7 +633,7 @@
         </p:nvSpPr>
         <p:spPr>
           <a:xfrm>
-            <a:off x="594360" y="1755648"/>
+            <a:off x="594360" y="1618488"/>
             <a:ext cx="310896" cy="310896"/>
           </a:xfrm>
           <a:prstGeom prst="ellipse">
@@ -674,7 +674,7 @@
         </p:nvSpPr>
         <p:spPr>
           <a:xfrm>
-            <a:off x="1005840" y="1737360"/>
+            <a:off x="1005840" y="1600200"/>
             <a:ext cx="3108960" cy="347472"/>
           </a:xfrm>
           <a:prstGeom prst="rect">
@@ -713,12 +713,12 @@
         </p:nvSpPr>
         <p:spPr>
           <a:xfrm>
-            <a:off x="4434840" y="1645920"/>
-            <a:ext cx="3794760" cy="1417320"/>
+            <a:off x="4389120" y="1508760"/>
+            <a:ext cx="3794760" cy="1508760"/>
           </a:xfrm>
           <a:prstGeom prst="rect">
             <a:avLst>
-              <a:gd name="adj" fmla="val 5161"/>
+              <a:gd name="adj" fmla="val 4848"/>
             </a:avLst>
           </a:prstGeom>
           <a:solidFill>
@@ -735,7 +735,7 @@
         </p:nvSpPr>
         <p:spPr>
           <a:xfrm>
-            <a:off x="4572000" y="1755648"/>
+            <a:off x="4526280" y="1618488"/>
             <a:ext cx="310896" cy="310896"/>
           </a:xfrm>
           <a:prstGeom prst="ellipse">
@@ -776,7 +776,7 @@
         </p:nvSpPr>
         <p:spPr>
           <a:xfrm>
-            <a:off x="4983480" y="1737360"/>
+            <a:off x="4937760" y="1600200"/>
             <a:ext cx="3108960" cy="347472"/>
           </a:xfrm>
           <a:prstGeom prst="rect">
@@ -815,12 +815,12 @@
         </p:nvSpPr>
         <p:spPr>
           <a:xfrm>
-            <a:off x="457200" y="3246120"/>
-            <a:ext cx="3794760" cy="1417320"/>
+            <a:off x="457200" y="3154680"/>
+            <a:ext cx="3794760" cy="1508760"/>
           </a:xfrm>
           <a:prstGeom prst="rect">
             <a:avLst>
-              <a:gd name="adj" fmla="val 5161"/>
+              <a:gd name="adj" fmla="val 4848"/>
             </a:avLst>
           </a:prstGeom>
           <a:solidFill>
@@ -837,7 +837,7 @@
         </p:nvSpPr>
         <p:spPr>
           <a:xfrm>
-            <a:off x="594360" y="3355848"/>
+            <a:off x="594360" y="3264408"/>
             <a:ext cx="310896" cy="310896"/>
           </a:xfrm>
           <a:prstGeom prst="ellipse">
@@ -878,7 +878,7 @@
         </p:nvSpPr>
         <p:spPr>
           <a:xfrm>
-            <a:off x="1005840" y="3337560"/>
+            <a:off x="1005840" y="3246120"/>
             <a:ext cx="3108960" cy="347472"/>
           </a:xfrm>
           <a:prstGeom prst="rect">
@@ -917,12 +917,12 @@
         </p:nvSpPr>
         <p:spPr>
           <a:xfrm>
-            <a:off x="4434840" y="3246120"/>
-            <a:ext cx="3794760" cy="1417320"/>
+            <a:off x="4389120" y="3154680"/>
+            <a:ext cx="3794760" cy="1508760"/>
           </a:xfrm>
           <a:prstGeom prst="rect">
             <a:avLst>
-              <a:gd name="adj" fmla="val 5161"/>
+              <a:gd name="adj" fmla="val 4848"/>
             </a:avLst>
           </a:prstGeom>
           <a:solidFill>
@@ -939,7 +939,7 @@
         </p:nvSpPr>
         <p:spPr>
           <a:xfrm>
-            <a:off x="4572000" y="3355848"/>
+            <a:off x="4526280" y="3264408"/>
             <a:ext cx="310896" cy="310896"/>
           </a:xfrm>
           <a:prstGeom prst="ellipse">
@@ -980,7 +980,7 @@
         </p:nvSpPr>
         <p:spPr>
           <a:xfrm>
-            <a:off x="4983480" y="3337560"/>
+            <a:off x="4937760" y="3246120"/>
             <a:ext cx="3108960" cy="347472"/>
           </a:xfrm>
           <a:prstGeom prst="rect">
@@ -1019,12 +1019,12 @@
         </p:nvSpPr>
         <p:spPr>
           <a:xfrm>
-            <a:off x="457200" y="4846320"/>
-            <a:ext cx="3794760" cy="1417320"/>
+            <a:off x="457200" y="4800600"/>
+            <a:ext cx="3794760" cy="1508760"/>
           </a:xfrm>
           <a:prstGeom prst="rect">
             <a:avLst>
-              <a:gd name="adj" fmla="val 5161"/>
+              <a:gd name="adj" fmla="val 4848"/>
             </a:avLst>
           </a:prstGeom>
           <a:solidFill>
@@ -1041,7 +1041,7 @@
         </p:nvSpPr>
         <p:spPr>
           <a:xfrm>
-            <a:off x="594360" y="4956048"/>
+            <a:off x="594360" y="4910328"/>
             <a:ext cx="310896" cy="310896"/>
           </a:xfrm>
           <a:prstGeom prst="ellipse">
@@ -1082,7 +1082,7 @@
         </p:nvSpPr>
         <p:spPr>
           <a:xfrm>
-            <a:off x="1005840" y="4937760"/>
+            <a:off x="1005840" y="4892040"/>
             <a:ext cx="3108960" cy="347472"/>
           </a:xfrm>
           <a:prstGeom prst="rect">
@@ -1121,12 +1121,12 @@
         </p:nvSpPr>
         <p:spPr>
           <a:xfrm>
-            <a:off x="4434840" y="4846320"/>
-            <a:ext cx="3794760" cy="1417320"/>
+            <a:off x="4389120" y="4800600"/>
+            <a:ext cx="3794760" cy="1508760"/>
           </a:xfrm>
           <a:prstGeom prst="rect">
             <a:avLst>
-              <a:gd name="adj" fmla="val 5161"/>
+              <a:gd name="adj" fmla="val 4848"/>
             </a:avLst>
           </a:prstGeom>
           <a:solidFill>
@@ -1143,7 +1143,7 @@
         </p:nvSpPr>
         <p:spPr>
           <a:xfrm>
-            <a:off x="4572000" y="4956048"/>
+            <a:off x="4526280" y="4910328"/>
             <a:ext cx="310896" cy="310896"/>
           </a:xfrm>
           <a:prstGeom prst="ellipse">
@@ -1184,7 +1184,7 @@
         </p:nvSpPr>
         <p:spPr>
           <a:xfrm>
-            <a:off x="4983480" y="4937760"/>
+            <a:off x="4937760" y="4892040"/>
             <a:ext cx="3108960" cy="347472"/>
           </a:xfrm>
           <a:prstGeom prst="rect">
@@ -1223,12 +1223,12 @@
         </p:nvSpPr>
         <p:spPr>
           <a:xfrm>
-            <a:off x="8412480" y="4480560"/>
-            <a:ext cx="3322015" cy="1783080"/>
+            <a:off x="8366760" y="4389120"/>
+            <a:ext cx="3367735" cy="1920240"/>
           </a:xfrm>
           <a:prstGeom prst="rect">
             <a:avLst>
-              <a:gd name="adj" fmla="val 4103"/>
+              <a:gd name="adj" fmla="val 3810"/>
             </a:avLst>
           </a:prstGeom>
           <a:solidFill>
@@ -1245,8 +1245,8 @@
         </p:nvSpPr>
         <p:spPr>
           <a:xfrm>
-            <a:off x="8549640" y="4572000"/>
-            <a:ext cx="3047695" cy="320040"/>
+            <a:off x="8503920" y="4480560"/>
+            <a:ext cx="3093415" cy="320040"/>
           </a:xfrm>
           <a:prstGeom prst="rect">
             <a:avLst/>
@@ -1286,8 +1286,8 @@
         </p:nvSpPr>
         <p:spPr>
           <a:xfrm>
-            <a:off x="621792" y="2148840"/>
-            <a:ext cx="3465576" cy="822960"/>
+            <a:off x="621792" y="1984248"/>
+            <a:ext cx="3465576" cy="960120"/>
           </a:xfrm>
           <a:prstGeom prst="rect">
             <a:avLst/>
@@ -1299,9 +1299,6 @@
           <a:bodyPr wrap="square" rtlCol="0"/>
           <a:lstStyle>
             <a:lvl1pPr indent="0" marL="0">
-              <a:lnSpc>
-                <a:spcPct val="110000"/>
-              </a:lnSpc>
               <a:buNone/>
               <a:defRPr lang="en-US" sz="1200" dirty="0">
                 <a:solidFill>
@@ -1315,9 +1312,6 @@
           </a:lstStyle>
           <a:p>
             <a:pPr indent="0" marL="0">
-              <a:lnSpc>
-                <a:spcPct val="110000"/>
-              </a:lnSpc>
               <a:buNone/>
             </a:pPr>
             <a:endParaRPr lang="en-US" sz="1200" dirty="0"/>
@@ -1334,8 +1328,8 @@
         </p:nvSpPr>
         <p:spPr>
           <a:xfrm>
-            <a:off x="4599432" y="2148840"/>
-            <a:ext cx="3465576" cy="822960"/>
+            <a:off x="4553712" y="1984248"/>
+            <a:ext cx="3465576" cy="960120"/>
           </a:xfrm>
           <a:prstGeom prst="rect">
             <a:avLst/>
@@ -1347,9 +1341,6 @@
           <a:bodyPr wrap="square" rtlCol="0"/>
           <a:lstStyle>
             <a:lvl1pPr indent="0" marL="0">
-              <a:lnSpc>
-                <a:spcPct val="110000"/>
-              </a:lnSpc>
               <a:buNone/>
               <a:defRPr lang="en-US" sz="1200" dirty="0">
                 <a:solidFill>
@@ -1363,9 +1354,6 @@
           </a:lstStyle>
           <a:p>
             <a:pPr indent="0" marL="0">
-              <a:lnSpc>
-                <a:spcPct val="110000"/>
-              </a:lnSpc>
               <a:buNone/>
             </a:pPr>
             <a:endParaRPr lang="en-US" sz="1200" dirty="0"/>
@@ -1382,8 +1370,8 @@
         </p:nvSpPr>
         <p:spPr>
           <a:xfrm>
-            <a:off x="621792" y="3749040"/>
-            <a:ext cx="3465576" cy="822960"/>
+            <a:off x="621792" y="3630168"/>
+            <a:ext cx="3465576" cy="960120"/>
           </a:xfrm>
           <a:prstGeom prst="rect">
             <a:avLst/>
@@ -1395,9 +1383,6 @@
           <a:bodyPr wrap="square" rtlCol="0"/>
           <a:lstStyle>
             <a:lvl1pPr indent="0" marL="0">
-              <a:lnSpc>
-                <a:spcPct val="110000"/>
-              </a:lnSpc>
               <a:buNone/>
               <a:defRPr lang="en-US" sz="1200" dirty="0">
                 <a:solidFill>
@@ -1411,9 +1396,6 @@
           </a:lstStyle>
           <a:p>
             <a:pPr indent="0" marL="0">
-              <a:lnSpc>
-                <a:spcPct val="110000"/>
-              </a:lnSpc>
               <a:buNone/>
             </a:pPr>
             <a:endParaRPr lang="en-US" sz="1200" dirty="0"/>
@@ -1430,8 +1412,8 @@
         </p:nvSpPr>
         <p:spPr>
           <a:xfrm>
-            <a:off x="4599432" y="3749040"/>
-            <a:ext cx="3465576" cy="822960"/>
+            <a:off x="4553712" y="3630168"/>
+            <a:ext cx="3465576" cy="960120"/>
           </a:xfrm>
           <a:prstGeom prst="rect">
             <a:avLst/>
@@ -1443,9 +1425,6 @@
           <a:bodyPr wrap="square" rtlCol="0"/>
           <a:lstStyle>
             <a:lvl1pPr indent="0" marL="0">
-              <a:lnSpc>
-                <a:spcPct val="110000"/>
-              </a:lnSpc>
               <a:buNone/>
               <a:defRPr lang="en-US" sz="1200" dirty="0">
                 <a:solidFill>
@@ -1459,9 +1438,6 @@
           </a:lstStyle>
           <a:p>
             <a:pPr indent="0" marL="0">
-              <a:lnSpc>
-                <a:spcPct val="110000"/>
-              </a:lnSpc>
               <a:buNone/>
             </a:pPr>
             <a:endParaRPr lang="en-US" sz="1200" dirty="0"/>
@@ -1478,8 +1454,8 @@
         </p:nvSpPr>
         <p:spPr>
           <a:xfrm>
-            <a:off x="621792" y="5349240"/>
-            <a:ext cx="3465576" cy="822960"/>
+            <a:off x="621792" y="5276088"/>
+            <a:ext cx="3465576" cy="960120"/>
           </a:xfrm>
           <a:prstGeom prst="rect">
             <a:avLst/>
@@ -1491,9 +1467,6 @@
           <a:bodyPr wrap="square" rtlCol="0"/>
           <a:lstStyle>
             <a:lvl1pPr indent="0" marL="0">
-              <a:lnSpc>
-                <a:spcPct val="110000"/>
-              </a:lnSpc>
               <a:buNone/>
               <a:defRPr lang="en-US" sz="1200" dirty="0">
                 <a:solidFill>
@@ -1507,9 +1480,6 @@
           </a:lstStyle>
           <a:p>
             <a:pPr indent="0" marL="0">
-              <a:lnSpc>
-                <a:spcPct val="110000"/>
-              </a:lnSpc>
               <a:buNone/>
             </a:pPr>
             <a:endParaRPr lang="en-US" sz="1200" dirty="0"/>
@@ -1526,8 +1496,8 @@
         </p:nvSpPr>
         <p:spPr>
           <a:xfrm>
-            <a:off x="4599432" y="5349240"/>
-            <a:ext cx="3465576" cy="822960"/>
+            <a:off x="4553712" y="5276088"/>
+            <a:ext cx="3465576" cy="960120"/>
           </a:xfrm>
           <a:prstGeom prst="rect">
             <a:avLst/>
@@ -1539,9 +1509,6 @@
           <a:bodyPr wrap="square" rtlCol="0"/>
           <a:lstStyle>
             <a:lvl1pPr indent="0" marL="0">
-              <a:lnSpc>
-                <a:spcPct val="110000"/>
-              </a:lnSpc>
               <a:buNone/>
               <a:defRPr lang="en-US" sz="1200" dirty="0">
                 <a:solidFill>
@@ -1555,9 +1522,6 @@
           </a:lstStyle>
           <a:p>
             <a:pPr indent="0" marL="0">
-              <a:lnSpc>
-                <a:spcPct val="110000"/>
-              </a:lnSpc>
               <a:buNone/>
             </a:pPr>
             <a:endParaRPr lang="en-US" sz="1200" dirty="0"/>
@@ -1575,7 +1539,7 @@
         <p:spPr>
           <a:xfrm>
             <a:off x="457200" y="274320"/>
-            <a:ext cx="11277295" cy="274320"/>
+            <a:ext cx="11277295" cy="256032"/>
           </a:xfrm>
           <a:prstGeom prst="rect">
             <a:avLst/>
@@ -1616,8 +1580,8 @@
         </p:nvSpPr>
         <p:spPr>
           <a:xfrm>
-            <a:off x="457200" y="566928"/>
-            <a:ext cx="11277295" cy="566928"/>
+            <a:off x="457200" y="548640"/>
+            <a:ext cx="11277295" cy="512064"/>
           </a:xfrm>
           <a:prstGeom prst="rect">
             <a:avLst/>
@@ -1658,8 +1622,8 @@
         </p:nvSpPr>
         <p:spPr>
           <a:xfrm>
-            <a:off x="457200" y="1152144"/>
-            <a:ext cx="11277295" cy="310896"/>
+            <a:off x="457200" y="1078992"/>
+            <a:ext cx="11277295" cy="292608"/>
           </a:xfrm>
           <a:prstGeom prst="rect">
             <a:avLst/>
@@ -1700,8 +1664,8 @@
         </p:nvSpPr>
         <p:spPr>
           <a:xfrm>
-            <a:off x="8549640" y="4937760"/>
-            <a:ext cx="3047695" cy="1234440"/>
+            <a:off x="8503920" y="4828032"/>
+            <a:ext cx="3093415" cy="1408176"/>
           </a:xfrm>
           <a:prstGeom prst="rect">
             <a:avLst/>
@@ -1713,9 +1677,6 @@
           <a:bodyPr wrap="square" rtlCol="0"/>
           <a:lstStyle>
             <a:lvl1pPr indent="0" marL="0">
-              <a:lnSpc>
-                <a:spcPct val="115000"/>
-              </a:lnSpc>
               <a:buNone/>
               <a:defRPr lang="en-US" sz="1050" dirty="0">
                 <a:solidFill>
@@ -1729,9 +1690,6 @@
           </a:lstStyle>
           <a:p>
             <a:pPr indent="0" marL="0">
-              <a:lnSpc>
-                <a:spcPct val="115000"/>
-              </a:lnSpc>
               <a:buNone/>
             </a:pPr>
             <a:endParaRPr lang="en-US" sz="1050" dirty="0"/>
@@ -1748,7 +1706,7 @@
         </p:nvSpPr>
         <p:spPr>
           <a:xfrm>
-            <a:off x="457200" y="6419088"/>
+            <a:off x="457200" y="6446520"/>
             <a:ext cx="9144000" cy="274320"/>
           </a:xfrm>
           <a:prstGeom prst="rect">
@@ -1792,7 +1750,7 @@
         </p:nvSpPr>
         <p:spPr>
           <a:xfrm>
-            <a:off x="11185855" y="6419088"/>
+            <a:off x="11185855" y="6446520"/>
             <a:ext cx="548640" cy="274320"/>
           </a:xfrm>
           <a:prstGeom prst="rect">
@@ -1823,6 +1781,254 @@
             <a:fld id="{F7021451-1387-4CA6-816F-3879F97B5CBC}" type="slidenum">
               <a:rPr b="0" lang="en-US"/>
               <a:t>1002</a:t>
+            </a:fld>
+            <a:endParaRPr lang="en-US"/>
+          </a:p>
+        </p:txBody>
+      </p:sp>
+    </p:spTree>
+  </p:cSld>
+  <p:clrMapOvr>
+    <a:masterClrMapping/>
+  </p:clrMapOvr>
+</p:sldLayout>
+</file>
+
+<file path=ppt/slideLayouts/slideLayout3.xml><?xml version="1.0" encoding="utf-8"?>
+<p:sldLayout xmlns:a="http://schemas.openxmlformats.org/drawingml/2006/main" xmlns:r="http://schemas.openxmlformats.org/officeDocument/2006/relationships" xmlns:p="http://schemas.openxmlformats.org/presentationml/2006/main" preserve="1">
+  <p:cSld name="OCHIAI_COVER">
+    <p:bg>
+      <p:bgPr>
+        <a:solidFill>
+          <a:srgbClr val="FFFFFF"/>
+        </a:solidFill>
+      </p:bgPr>
+    </p:bg>
+    <p:spTree>
+      <p:nvGrpSpPr>
+        <p:cNvPr id="1" name=""/>
+        <p:cNvGrpSpPr/>
+        <p:nvPr/>
+      </p:nvGrpSpPr>
+      <p:grpSpPr>
+        <a:xfrm>
+          <a:off x="0" y="0"/>
+          <a:ext cx="0" cy="0"/>
+          <a:chOff x="0" y="0"/>
+          <a:chExt cx="0" cy="0"/>
+        </a:xfrm>
+      </p:grpSpPr>
+      <p:sp>
+        <p:nvSpPr>
+          <p:cNvPr id="2" name="Text 0"/>
+          <p:cNvSpPr/>
+          <p:nvPr>
+            <p:ph idx="100" type="body" hasCustomPrompt="1"/>
+          </p:nvPr>
+        </p:nvSpPr>
+        <p:spPr>
+          <a:xfrm>
+            <a:off x="457200" y="411480"/>
+            <a:ext cx="11277295" cy="274320"/>
+          </a:xfrm>
+          <a:prstGeom prst="rect">
+            <a:avLst/>
+          </a:prstGeom>
+          <a:noFill/>
+          <a:ln/>
+        </p:spPr>
+        <p:txBody>
+          <a:bodyPr wrap="square" rtlCol="0"/>
+          <a:lstStyle>
+            <a:lvl1pPr indent="0" marL="0">
+              <a:buNone/>
+              <a:defRPr lang="en-US" sz="1200" b="1" dirty="0">
+                <a:solidFill>
+                  <a:srgbClr val="1F6F78"/>
+                </a:solidFill>
+                <a:latin typeface="Meiryo" pitchFamily="34" charset="0"/>
+                <a:ea typeface="Meiryo" pitchFamily="34" charset="-122"/>
+                <a:cs typeface="Meiryo" pitchFamily="34" charset="-120"/>
+              </a:defRPr>
+            </a:lvl1pPr>
+          </a:lstStyle>
+          <a:p>
+            <a:pPr indent="0" marL="0">
+              <a:buNone/>
+            </a:pPr>
+            <a:endParaRPr lang="en-US" sz="1200" dirty="0"/>
+          </a:p>
+        </p:txBody>
+      </p:sp>
+      <p:sp>
+        <p:nvSpPr>
+          <p:cNvPr id="3" name="Text 0"/>
+          <p:cNvSpPr/>
+          <p:nvPr>
+            <p:ph idx="101" type="body" hasCustomPrompt="1"/>
+          </p:nvPr>
+        </p:nvSpPr>
+        <p:spPr>
+          <a:xfrm>
+            <a:off x="457200" y="731520"/>
+            <a:ext cx="11277295" cy="685800"/>
+          </a:xfrm>
+          <a:prstGeom prst="rect">
+            <a:avLst/>
+          </a:prstGeom>
+          <a:noFill/>
+          <a:ln/>
+        </p:spPr>
+        <p:txBody>
+          <a:bodyPr wrap="square" rtlCol="0"/>
+          <a:lstStyle>
+            <a:lvl1pPr indent="0" marL="0">
+              <a:buNone/>
+              <a:defRPr lang="en-US" sz="3600" b="1" dirty="0">
+                <a:solidFill>
+                  <a:srgbClr val="1E2433"/>
+                </a:solidFill>
+                <a:latin typeface="Meiryo" pitchFamily="34" charset="0"/>
+                <a:ea typeface="Meiryo" pitchFamily="34" charset="-122"/>
+                <a:cs typeface="Meiryo" pitchFamily="34" charset="-120"/>
+              </a:defRPr>
+            </a:lvl1pPr>
+          </a:lstStyle>
+          <a:p>
+            <a:pPr indent="0" marL="0">
+              <a:buNone/>
+            </a:pPr>
+            <a:endParaRPr lang="en-US" sz="3600" dirty="0"/>
+          </a:p>
+        </p:txBody>
+      </p:sp>
+      <p:sp>
+        <p:nvSpPr>
+          <p:cNvPr id="4" name="Text 0"/>
+          <p:cNvSpPr/>
+          <p:nvPr>
+            <p:ph idx="102" type="body" hasCustomPrompt="1"/>
+          </p:nvPr>
+        </p:nvSpPr>
+        <p:spPr>
+          <a:xfrm>
+            <a:off x="457200" y="1508760"/>
+            <a:ext cx="11277295" cy="822960"/>
+          </a:xfrm>
+          <a:prstGeom prst="rect">
+            <a:avLst/>
+          </a:prstGeom>
+          <a:noFill/>
+          <a:ln/>
+        </p:spPr>
+        <p:txBody>
+          <a:bodyPr wrap="square" rtlCol="0"/>
+          <a:lstStyle>
+            <a:lvl1pPr indent="0" marL="0">
+              <a:buNone/>
+              <a:defRPr lang="en-US" sz="1300" dirty="0">
+                <a:solidFill>
+                  <a:srgbClr val="5B6478"/>
+                </a:solidFill>
+                <a:latin typeface="Meiryo" pitchFamily="34" charset="0"/>
+                <a:ea typeface="Meiryo" pitchFamily="34" charset="-122"/>
+                <a:cs typeface="Meiryo" pitchFamily="34" charset="-120"/>
+              </a:defRPr>
+            </a:lvl1pPr>
+          </a:lstStyle>
+          <a:p>
+            <a:pPr indent="0" marL="0">
+              <a:buNone/>
+            </a:pPr>
+            <a:endParaRPr lang="en-US" sz="1300" dirty="0"/>
+          </a:p>
+        </p:txBody>
+      </p:sp>
+      <p:sp>
+        <p:nvSpPr>
+          <p:cNvPr id="5" name="Text 0"/>
+          <p:cNvSpPr/>
+          <p:nvPr>
+            <p:ph idx="103" type="body" hasCustomPrompt="1"/>
+          </p:nvPr>
+        </p:nvSpPr>
+        <p:spPr>
+          <a:xfrm>
+            <a:off x="457200" y="6446520"/>
+            <a:ext cx="9144000" cy="274320"/>
+          </a:xfrm>
+          <a:prstGeom prst="rect">
+            <a:avLst/>
+          </a:prstGeom>
+          <a:noFill/>
+          <a:ln/>
+        </p:spPr>
+        <p:txBody>
+          <a:bodyPr wrap="square" rtlCol="0"/>
+          <a:lstStyle>
+            <a:lvl1pPr indent="0" marL="0">
+              <a:buNone/>
+              <a:defRPr lang="en-US" sz="1000" dirty="0">
+                <a:solidFill>
+                  <a:srgbClr val="5B6478"/>
+                </a:solidFill>
+                <a:latin typeface="Meiryo" pitchFamily="34" charset="0"/>
+                <a:ea typeface="Meiryo" pitchFamily="34" charset="-122"/>
+                <a:cs typeface="Meiryo" pitchFamily="34" charset="-120"/>
+              </a:defRPr>
+            </a:lvl1pPr>
+          </a:lstStyle>
+          <a:p>
+            <a:pPr indent="0" marL="0">
+              <a:buNone/>
+            </a:pPr>
+            <a:endParaRPr lang="en-US" sz="1000" dirty="0"/>
+          </a:p>
+        </p:txBody>
+      </p:sp>
+      <p:sp>
+        <p:nvSpPr>
+          <p:cNvPr id="25" name="Slide Number Placeholder 0"/>
+          <p:cNvSpPr>
+            <a:spLocks noGrp="1"/>
+          </p:cNvSpPr>
+          <p:nvPr>
+            <p:ph type="sldNum" sz="quarter" idx="4294967295"/>
+          </p:nvPr>
+        </p:nvSpPr>
+        <p:spPr>
+          <a:xfrm>
+            <a:off x="11185855" y="6446520"/>
+            <a:ext cx="548640" cy="274320"/>
+          </a:xfrm>
+          <a:prstGeom prst="rect">
+            <a:avLst/>
+          </a:prstGeom>
+          <a:extLst>
+            <a:ext uri="{C572A759-6A51-4108-AA02-DFA0A04FC94B}">
+              <ma14:wrappingTextBoxFlag xmlns:ma14="http://schemas.microsoft.com/office/mac/drawingml/2011/main" val="0"/>
+            </a:ext>
+          </a:extLst>
+        </p:spPr>
+        <p:txBody>
+          <a:bodyPr/>
+          <a:lstStyle>
+            <a:lvl1pPr>
+              <a:defRPr sz="1000">
+                <a:solidFill>
+                  <a:srgbClr val="5B6478"/>
+                </a:solidFill>
+                <a:latin typeface="Meiryo"/>
+                <a:ea typeface="Meiryo"/>
+                <a:cs typeface="Meiryo"/>
+              </a:defRPr>
+            </a:lvl1pPr>
+          </a:lstStyle>
+          <a:p>
+            <a:pPr algn="r"/>
+            <a:fld id="{F7021451-1387-4CA6-816F-3879F97B5CBC}" type="slidenum">
+              <a:rPr b="0" lang="en-US"/>
+              <a:t>1003</a:t>
             </a:fld>
             <a:endParaRPr lang="en-US"/>
           </a:p>
@@ -1865,7 +2071,7 @@
         </p:nvSpPr>
         <p:spPr>
           <a:xfrm>
-            <a:off x="11185855" y="6419088"/>
+            <a:off x="11185855" y="6446520"/>
             <a:ext cx="548640" cy="274320"/>
           </a:xfrm>
           <a:prstGeom prst="rect">
@@ -1907,6 +2113,7 @@
   <p:sldLayoutIdLst>
     <p:sldLayoutId id="2147483649" r:id="rId1"/>
     <p:sldLayoutId id="2147483650" r:id="rId2"/>
+    <p:sldLayoutId id="2147483651" r:id="rId3"/>
   </p:sldLayoutIdLst>
   <p:hf sldNum="0" hdr="0" ftr="0" dt="0"/>
   <p:txStyles>
@@ -2190,7 +2397,7 @@
         <p:spPr>
           <a:xfrm>
             <a:off x="457200" y="274320"/>
-            <a:ext cx="11277295" cy="274320"/>
+            <a:ext cx="11277295" cy="256032"/>
           </a:xfrm>
           <a:prstGeom prst="rect">
             <a:avLst/>
@@ -2230,8 +2437,8 @@
         </p:nvSpPr>
         <p:spPr>
           <a:xfrm>
-            <a:off x="457200" y="566928"/>
-            <a:ext cx="11277295" cy="566928"/>
+            <a:off x="457200" y="548640"/>
+            <a:ext cx="11277295" cy="512064"/>
           </a:xfrm>
           <a:prstGeom prst="rect">
             <a:avLst/>
@@ -2240,9 +2447,7 @@
           <a:ln/>
         </p:spPr>
         <p:txBody>
-          <a:bodyPr wrap="square" lIns="0" tIns="0" rIns="0" bIns="0" rtlCol="0" anchor="ctr">
-            <a:normAutofit/>
-          </a:bodyPr>
+          <a:bodyPr wrap="square" lIns="0" tIns="0" rIns="0" bIns="0" rtlCol="0" anchor="ctr"/>
           <a:lstStyle/>
           <a:p>
             <a:pPr indent="0" marL="0">
@@ -2273,8 +2478,8 @@
         </p:nvSpPr>
         <p:spPr>
           <a:xfrm>
-            <a:off x="457200" y="1152144"/>
-            <a:ext cx="11277295" cy="310896"/>
+            <a:off x="457200" y="1078992"/>
+            <a:ext cx="11277295" cy="292608"/>
           </a:xfrm>
           <a:prstGeom prst="rect">
             <a:avLst/>
@@ -2314,8 +2519,8 @@
         </p:nvSpPr>
         <p:spPr>
           <a:xfrm>
-            <a:off x="621792" y="2148840"/>
-            <a:ext cx="3465576" cy="822960"/>
+            <a:off x="621792" y="1984248"/>
+            <a:ext cx="3465576" cy="960120"/>
           </a:xfrm>
           <a:prstGeom prst="rect">
             <a:avLst/>
@@ -2329,7 +2534,7 @@
           <a:p>
             <a:pPr indent="0" marL="0">
               <a:lnSpc>
-                <a:spcPct val="110000"/>
+                <a:spcPts val="1600"/>
               </a:lnSpc>
               <a:buNone/>
             </a:pPr>
@@ -2358,8 +2563,8 @@
         </p:nvSpPr>
         <p:spPr>
           <a:xfrm>
-            <a:off x="4599432" y="2148840"/>
-            <a:ext cx="3465576" cy="822960"/>
+            <a:off x="4553712" y="1984248"/>
+            <a:ext cx="3465576" cy="960120"/>
           </a:xfrm>
           <a:prstGeom prst="rect">
             <a:avLst/>
@@ -2373,7 +2578,7 @@
           <a:p>
             <a:pPr indent="0" marL="0">
               <a:lnSpc>
-                <a:spcPct val="110000"/>
+                <a:spcPts val="1600"/>
               </a:lnSpc>
               <a:buNone/>
             </a:pPr>
@@ -2402,8 +2607,8 @@
         </p:nvSpPr>
         <p:spPr>
           <a:xfrm>
-            <a:off x="621792" y="3749040"/>
-            <a:ext cx="3465576" cy="822960"/>
+            <a:off x="621792" y="3630168"/>
+            <a:ext cx="3465576" cy="960120"/>
           </a:xfrm>
           <a:prstGeom prst="rect">
             <a:avLst/>
@@ -2417,7 +2622,7 @@
           <a:p>
             <a:pPr indent="0" marL="0">
               <a:lnSpc>
-                <a:spcPct val="110000"/>
+                <a:spcPts val="1600"/>
               </a:lnSpc>
               <a:buNone/>
             </a:pPr>
@@ -2446,8 +2651,8 @@
         </p:nvSpPr>
         <p:spPr>
           <a:xfrm>
-            <a:off x="4599432" y="3749040"/>
-            <a:ext cx="3465576" cy="822960"/>
+            <a:off x="4553712" y="3630168"/>
+            <a:ext cx="3465576" cy="960120"/>
           </a:xfrm>
           <a:prstGeom prst="rect">
             <a:avLst/>
@@ -2461,7 +2666,7 @@
           <a:p>
             <a:pPr indent="0" marL="0">
               <a:lnSpc>
-                <a:spcPct val="110000"/>
+                <a:spcPts val="1600"/>
               </a:lnSpc>
               <a:buNone/>
             </a:pPr>
@@ -2490,8 +2695,8 @@
         </p:nvSpPr>
         <p:spPr>
           <a:xfrm>
-            <a:off x="621792" y="5349240"/>
-            <a:ext cx="3465576" cy="822960"/>
+            <a:off x="621792" y="5276088"/>
+            <a:ext cx="3465576" cy="960120"/>
           </a:xfrm>
           <a:prstGeom prst="rect">
             <a:avLst/>
@@ -2505,7 +2710,7 @@
           <a:p>
             <a:pPr indent="0" marL="0">
               <a:lnSpc>
-                <a:spcPct val="110000"/>
+                <a:spcPts val="1600"/>
               </a:lnSpc>
               <a:buNone/>
             </a:pPr>
@@ -2534,8 +2739,8 @@
         </p:nvSpPr>
         <p:spPr>
           <a:xfrm>
-            <a:off x="4599432" y="5349240"/>
-            <a:ext cx="3465576" cy="822960"/>
+            <a:off x="4553712" y="5276088"/>
+            <a:ext cx="3465576" cy="960120"/>
           </a:xfrm>
           <a:prstGeom prst="rect">
             <a:avLst/>
@@ -2549,7 +2754,7 @@
           <a:p>
             <a:pPr indent="0" marL="0">
               <a:lnSpc>
-                <a:spcPct val="110000"/>
+                <a:spcPts val="1600"/>
               </a:lnSpc>
               <a:buNone/>
             </a:pPr>
@@ -2578,8 +2783,8 @@
         </p:nvSpPr>
         <p:spPr>
           <a:xfrm>
-            <a:off x="8549640" y="4937760"/>
-            <a:ext cx="3047695" cy="1234440"/>
+            <a:off x="8503920" y="4828032"/>
+            <a:ext cx="3093415" cy="1408176"/>
           </a:xfrm>
           <a:prstGeom prst="rect">
             <a:avLst/>
@@ -2593,7 +2798,7 @@
           <a:p>
             <a:pPr indent="0" marL="0">
               <a:lnSpc>
-                <a:spcPct val="115000"/>
+                <a:spcPts val="1400"/>
               </a:lnSpc>
               <a:buNone/>
             </a:pPr>
@@ -2610,7 +2815,7 @@
             </a:r>
             <a:pPr indent="0" marL="0">
               <a:lnSpc>
-                <a:spcPct val="115000"/>
+                <a:spcPts val="1400"/>
               </a:lnSpc>
               <a:buNone/>
             </a:pPr>
@@ -2630,7 +2835,7 @@
           <a:p>
             <a:pPr indent="0" marL="0">
               <a:lnSpc>
-                <a:spcPct val="115000"/>
+                <a:spcPts val="1400"/>
               </a:lnSpc>
               <a:buNone/>
             </a:pPr>
@@ -2647,7 +2852,7 @@
             </a:r>
             <a:pPr indent="0" marL="0">
               <a:lnSpc>
-                <a:spcPct val="115000"/>
+                <a:spcPts val="1400"/>
               </a:lnSpc>
               <a:buNone/>
             </a:pPr>
@@ -2667,7 +2872,7 @@
           <a:p>
             <a:pPr indent="0" marL="0">
               <a:lnSpc>
-                <a:spcPct val="115000"/>
+                <a:spcPts val="1400"/>
               </a:lnSpc>
               <a:buNone/>
             </a:pPr>
@@ -2684,7 +2889,7 @@
             </a:r>
             <a:pPr indent="0" marL="0">
               <a:lnSpc>
-                <a:spcPct val="115000"/>
+                <a:spcPts val="1400"/>
               </a:lnSpc>
               <a:buNone/>
             </a:pPr>
@@ -2704,7 +2909,7 @@
           <a:p>
             <a:pPr indent="0" marL="0">
               <a:lnSpc>
-                <a:spcPct val="115000"/>
+                <a:spcPts val="1400"/>
               </a:lnSpc>
               <a:buNone/>
             </a:pPr>
@@ -2721,7 +2926,7 @@
             </a:r>
             <a:pPr indent="0" marL="0">
               <a:lnSpc>
-                <a:spcPct val="115000"/>
+                <a:spcPts val="1400"/>
               </a:lnSpc>
               <a:buNone/>
             </a:pPr>
@@ -2741,7 +2946,7 @@
           <a:p>
             <a:pPr indent="0" marL="0">
               <a:lnSpc>
-                <a:spcPct val="115000"/>
+                <a:spcPts val="1400"/>
               </a:lnSpc>
               <a:buNone/>
             </a:pPr>
@@ -2758,7 +2963,7 @@
             </a:r>
             <a:pPr indent="0" marL="0">
               <a:lnSpc>
-                <a:spcPct val="115000"/>
+                <a:spcPts val="1400"/>
               </a:lnSpc>
               <a:buNone/>
             </a:pPr>
@@ -2787,7 +2992,7 @@
         </p:nvSpPr>
         <p:spPr>
           <a:xfrm>
-            <a:off x="457200" y="6419088"/>
+            <a:off x="457200" y="6446520"/>
             <a:ext cx="9144000" cy="274320"/>
           </a:xfrm>
           <a:prstGeom prst="rect">
@@ -2826,12 +3031,12 @@
         </p:nvSpPr>
         <p:spPr>
           <a:xfrm>
-            <a:off x="8412480" y="1645920"/>
-            <a:ext cx="3322015" cy="2651760"/>
+            <a:off x="8366760" y="1508760"/>
+            <a:ext cx="3367735" cy="2743200"/>
           </a:xfrm>
           <a:prstGeom prst="roundRect">
             <a:avLst>
-              <a:gd name="adj" fmla="val 2759"/>
+              <a:gd name="adj" fmla="val 2667"/>
             </a:avLst>
           </a:prstGeom>
           <a:solidFill>
@@ -2853,8 +3058,8 @@
         </p:nvSpPr>
         <p:spPr>
           <a:xfrm>
-            <a:off x="8641080" y="1874520"/>
-            <a:ext cx="2864815" cy="2194560"/>
+            <a:off x="8595360" y="1737360"/>
+            <a:ext cx="2910535" cy="2286000"/>
           </a:xfrm>
           <a:prstGeom prst="rect">
             <a:avLst/>
@@ -2919,7 +3124,7 @@
         </p:nvSpPr>
         <p:spPr>
           <a:xfrm>
-            <a:off x="11185855" y="6419088"/>
+            <a:off x="11185855" y="6446520"/>
             <a:ext cx="548640" cy="274320"/>
           </a:xfrm>
           <a:prstGeom prst="rect">

</xml_diff>

<commit_message>
Fix title/author auto-sizing so long original titles shrink instead of wrapping
Co-Authored-By: Claude Opus 5.5 <noreply@anthropic.com>
Claude-Session: https://claude.ai/code/session_01XCo1fEaxRp1ZKVxVZ14mEu
</commit_message>
<xml_diff>
--- a/template/ochiai_format_template.pptx
+++ b/template/ochiai_format_template.pptx
@@ -1580,8 +1580,8 @@
         </p:nvSpPr>
         <p:spPr>
           <a:xfrm>
-            <a:off x="457200" y="548640"/>
-            <a:ext cx="11277295" cy="512064"/>
+            <a:off x="457200" y="530352"/>
+            <a:ext cx="11277295" cy="566928"/>
           </a:xfrm>
           <a:prstGeom prst="rect">
             <a:avLst/>
@@ -1622,8 +1622,8 @@
         </p:nvSpPr>
         <p:spPr>
           <a:xfrm>
-            <a:off x="457200" y="1078992"/>
-            <a:ext cx="11277295" cy="292608"/>
+            <a:off x="457200" y="1115568"/>
+            <a:ext cx="11277295" cy="274320"/>
           </a:xfrm>
           <a:prstGeom prst="rect">
             <a:avLst/>
@@ -2437,8 +2437,8 @@
         </p:nvSpPr>
         <p:spPr>
           <a:xfrm>
-            <a:off x="457200" y="548640"/>
-            <a:ext cx="11277295" cy="512064"/>
+            <a:off x="457200" y="530352"/>
+            <a:ext cx="11277295" cy="566928"/>
           </a:xfrm>
           <a:prstGeom prst="rect">
             <a:avLst/>
@@ -2451,6 +2451,9 @@
           <a:lstStyle/>
           <a:p>
             <a:pPr indent="0" marL="0">
+              <a:lnSpc>
+                <a:spcPts val="3250"/>
+              </a:lnSpc>
               <a:buNone/>
             </a:pPr>
             <a:r>
@@ -2478,8 +2481,8 @@
         </p:nvSpPr>
         <p:spPr>
           <a:xfrm>
-            <a:off x="457200" y="1078992"/>
-            <a:ext cx="11277295" cy="292608"/>
+            <a:off x="457200" y="1115568"/>
+            <a:ext cx="11277295" cy="274320"/>
           </a:xfrm>
           <a:prstGeom prst="rect">
             <a:avLst/>

</xml_diff>